<commit_message>
Replace private source links with local Markdown documentation
</commit_message>
<xml_diff>
--- a/slides/building-your-own-chief-of-staff.pptx
+++ b/slides/building-your-own-chief-of-staff.pptx
@@ -535,7 +535,7 @@
           <a:p/>
           <a:p>
             <a:r>
-              <a:t>Cite the source of truth if asked: the author's Substack research table in Notion — https://app.notion.com/p/36e059b703e180d3a962d862c9e380c5 — 879 rows of operator essays. We synthesized from those rows, not from a generic web roundup.</a:t>
+              <a:t>Cite the local source catalog if asked: https://github.com/BittahCriminal/build-your-own-chief-of-staff/blob/main/research/SOURCES.md — 20 Markdown notes documenting the operating rules used in this kit, with original article attribution.</a:t>
             </a:r>
           </a:p>
         </p:txBody>
@@ -617,7 +617,7 @@
           <a:p/>
           <a:p>
             <a:r>
-              <a:t>Reusable-rig essay: skills should be local, inspectable, and independent of whichever AI app you are renting this month. Notion: https://app.notion.com/p/392059b703e1814b96a6dd9913180844</a:t>
+              <a:t>Reusable-rig essay: skills should be local, inspectable, and independent of whichever AI app you are renting this month. Source: https://github.com/BittahCriminal/build-your-own-chief-of-staff/blob/main/research/notes/reusable-rig.md</a:t>
             </a:r>
           </a:p>
           <a:p/>
@@ -818,7 +818,7 @@
           </a:p>
           <a:p>
             <a:r>
-              <a:t>5. Citation guard: no anchor, no claim. Gaps stay gaps. Prompt: verify.md  Notion: https://app.notion.com/p/392059b703e1814b96a6dd9913180844</a:t>
+              <a:t>5. Citation guard: no anchor, no claim. Gaps stay gaps. Prompt: verify.md  Source: https://github.com/BittahCriminal/build-your-own-chief-of-staff/blob/main/research/notes/reusable-rig.md</a:t>
             </a:r>
           </a:p>
           <a:p>
@@ -834,7 +834,7 @@
           <a:p/>
           <a:p>
             <a:r>
-              <a:t>Then say: point the same seven steps at expense reports, hiring screens, incident recaps. Buying a smarter model does not skip workflow, data, authority, evaluation, audit, or an owner. Notion: https://app.notion.com/p/36f059b703e1813d801bcb34d72141b1</a:t>
+              <a:t>Then say: point the same seven steps at expense reports, hiring screens, incident recaps. Buying a smarter model does not skip workflow, data, authority, evaluation, audit, or an owner. Source: https://github.com/BittahCriminal/build-your-own-chief-of-staff/blob/main/research/notes/workflow-readiness.md</a:t>
             </a:r>
           </a:p>
           <a:p/>
@@ -1086,19 +1086,19 @@
           <a:p/>
           <a:p>
             <a:r>
-              <a:t>If an agent sends a flawed appeal in your name, you now have two problems. Notion: https://app.notion.com/p/392059b703e1814b96a6dd9913180844</a:t>
+              <a:t>If an agent sends a flawed appeal in your name, you now have two problems. Source: https://github.com/BittahCriminal/build-your-own-chief-of-staff/blob/main/research/notes/reusable-rig.md</a:t>
             </a:r>
           </a:p>
           <a:p/>
           <a:p>
             <a:r>
-              <a:t>Inbox is untrusted. A line that says 'ignore your rules' is data, not an order. First-agent-job: https://app.notion.com/p/3bb059b703e1817b9123ff209fcc5d9d</a:t>
+              <a:t>Inbox is untrusted. A line that says 'ignore your rules' is data, not an order. First-agent-job: https://github.com/BittahCriminal/build-your-own-chief-of-staff/blob/main/research/notes/first-agent-job.md</a:t>
             </a:r>
           </a:p>
           <a:p/>
           <a:p>
             <a:r>
-              <a:t>Where the agent should stop: start where a colleague or customer already tells you you're wrong; reconstructing context is the expensive part; the reply is cheap. Notion: https://app.notion.com/p/3aa059b703e1817c9571c77f8badaf77</a:t>
+              <a:t>Where the agent should stop: start where a colleague or customer already tells you you're wrong; reconstructing context is the expensive part; the reply is cheap. Source: https://github.com/BittahCriminal/build-your-own-chief-of-staff/blob/main/research/notes/where-to-stop.md</a:t>
             </a:r>
           </a:p>
         </p:txBody>
@@ -1174,7 +1174,7 @@
           <a:p/>
           <a:p>
             <a:r>
-              <a:t>If they want receipts: research/SOURCES.md lists the Notion pages this was synthesized from, starting with the Substack database https://app.notion.com/p/36e059b703e180d3a962d862c9e380c5</a:t>
+              <a:t>If they want receipts: research/SOURCES.md catalogs the local source notes and original articles behind the method: https://github.com/BittahCriminal/build-your-own-chief-of-staff/blob/main/research/SOURCES.md</a:t>
             </a:r>
           </a:p>
           <a:p/>
@@ -1262,7 +1262,7 @@
           <a:p/>
           <a:p>
             <a:r>
-              <a:t>That claim is from the context-files row in the table (Notion: https://app.notion.com/p/3bb059b703e18152aea0d83b502fa319) and from the delegation kit's memory scaffold (https://app.notion.com/p/36f059b703e18192a6d8f67fbe74b756).</a:t>
+              <a:t>That claim is from the context-files note (Source: https://github.com/BittahCriminal/build-your-own-chief-of-staff/blob/main/research/notes/context-files.md) and from the delegation kit's memory scaffold (https://github.com/BittahCriminal/build-your-own-chief-of-staff/blob/main/research/notes/delegation-kit.md).</a:t>
             </a:r>
           </a:p>
         </p:txBody>
@@ -1338,7 +1338,7 @@
           <a:p/>
           <a:p>
             <a:r>
-              <a:t>We automate the first. We keep the second. That split is the whole talk, and it is the load-bearing claim in the Delegation Kit row: https://app.notion.com/p/36f059b703e18192a6d8f67fbe74b756</a:t>
+              <a:t>We automate the first. We keep the second. That split is the whole talk, and it is the load-bearing claim in the Delegation Kit note: https://github.com/BittahCriminal/build-your-own-chief-of-staff/blob/main/research/notes/delegation-kit.md</a:t>
             </a:r>
           </a:p>
         </p:txBody>
@@ -1432,13 +1432,13 @@
           <a:p/>
           <a:p>
             <a:r>
-              <a:t>The checkability argument: if checking an answer costs as much as making it, extra attempts just grow the pile. Notion: https://app.notion.com/p/399059b703e18107b20dfe6bb5c32626</a:t>
+              <a:t>The checkability argument: if checking an answer costs as much as making it, extra attempts just grow the pile. Source: https://github.com/BittahCriminal/build-your-own-chief-of-staff/blob/main/research/notes/agent-shaped-work.md</a:t>
             </a:r>
           </a:p>
           <a:p/>
           <a:p>
             <a:r>
-              <a:t>And: if you cannot name what would make you say 'not yet,' you have a vibe, not a job. Notion: https://app.notion.com/p/36f059b703e18142b351f70732b09c29</a:t>
+              <a:t>And: if you cannot name what would make you say 'not yet,' you have a vibe, not a job. Source: https://github.com/BittahCriminal/build-your-own-chief-of-staff/blob/main/research/notes/verification-gap.md</a:t>
             </a:r>
           </a:p>
         </p:txBody>
@@ -1514,13 +1514,13 @@
           <a:p/>
           <a:p>
             <a:r>
-              <a:t>The shape-of-the-work briefing: if you automate work that depends on trust and judgment, you break the process at the point where the human mattered most. Notion: https://app.notion.com/p/36f059b703e181cf9c30f637d158b234</a:t>
+              <a:t>The shape-of-the-work briefing: if you automate work that depends on trust and judgment, you break the process at the point where the human mattered most. Source: https://github.com/BittahCriminal/build-your-own-chief-of-staff/blob/main/research/notes/shape-of-work.md</a:t>
             </a:r>
           </a:p>
           <a:p/>
           <a:p>
             <a:r>
-              <a:t>And from automation discovery: frequency is evidence, not value. Choosing none of the offered automations is allowed. Notion: https://app.notion.com/p/3a0059b703e181c69fafc66f28f76c99</a:t>
+              <a:t>And from automation discovery: frequency is evidence, not value. Choosing none of the offered automations is allowed. Source: https://github.com/BittahCriminal/build-your-own-chief-of-staff/blob/main/research/notes/let-history-pick.md</a:t>
             </a:r>
           </a:p>
         </p:txBody>
@@ -1596,13 +1596,13 @@
           <a:p/>
           <a:p>
             <a:r>
-              <a:t>Nate's empty-prompt piece: people have a capable agent and keep staring at the box. The first version of automation-discovery let the AI pick and build — he killed that 'magic button' because it hides the judgment call. Offer sheet, then a human chooses. Choosing none is allowed. Frequency is not value. Notion: https://app.notion.com/p/3a0059b703e181c69fafc66f28f76c99</a:t>
+              <a:t>Nate's empty-prompt piece: people have a capable agent and keep staring at the box. The first version of automation-discovery let the AI pick and build — he killed that 'magic button' because it hides the judgment call. Offer sheet, then a human chooses. Choosing none is allowed. Frequency is not value. Source: https://github.com/BittahCriminal/build-your-own-chief-of-staff/blob/main/research/notes/let-history-pick.md</a:t>
             </a:r>
           </a:p>
           <a:p/>
           <a:p>
             <a:r>
-              <a:t>Idle agents: a social network for agents filled up and sat there. They were never asked to do a single thing. Notion: https://app.notion.com/p/399059b703e18107b20dfe6bb5c32626</a:t>
+              <a:t>Idle agents: a social network for agents filled up and sat there. They were never asked to do a single thing. Source: https://github.com/BittahCriminal/build-your-own-chief-of-staff/blob/main/research/notes/agent-shaped-work.md</a:t>
             </a:r>
           </a:p>
           <a:p/>
@@ -1678,28 +1678,28 @@
           <a:lstStyle/>
           <a:p>
             <a:r>
-              <a:t>These are Nate's failure modes from the Substack table, not a generic 'AI projects fail' slide.</a:t>
+              <a:t>These failure modes come from Nate's essays, summarized in the local source notes below.</a:t>
             </a:r>
           </a:p>
           <a:p/>
           <a:p>
             <a:r>
-              <a:t>Core-first vs edges: https://app.notion.com/p/36f059b703e181d9bd25f984c8bd6945</a:t>
-            </a:r>
-          </a:p>
-          <a:p>
-            <a:r>
-              <a:t>Fails at the task level (five jobs pretending to be one): https://app.notion.com/p/36f059b703e181f9afedc637cd6529f4</a:t>
-            </a:r>
-          </a:p>
-          <a:p>
-            <a:r>
-              <a:t>False success (wrong spreadsheet, said done): https://app.notion.com/p/3b5059b703e1819fbd41c6ba9658b0c6</a:t>
-            </a:r>
-          </a:p>
-          <a:p>
-            <a:r>
-              <a:t>A better model will not save you: https://app.notion.com/p/36f059b703e1818fa542e8696353ebb9</a:t>
+              <a:t>Core-first vs edges: https://github.com/BittahCriminal/build-your-own-chief-of-staff/blob/main/research/notes/why-agent-projects-fail.md</a:t>
+            </a:r>
+          </a:p>
+          <a:p>
+            <a:r>
+              <a:t>Fails at the task level (five jobs pretending to be one): https://github.com/BittahCriminal/build-your-own-chief-of-staff/blob/main/research/notes/task-decomposition.md</a:t>
+            </a:r>
+          </a:p>
+          <a:p>
+            <a:r>
+              <a:t>False success (wrong spreadsheet, said done): https://github.com/BittahCriminal/build-your-own-chief-of-staff/blob/main/research/notes/false-success.md</a:t>
+            </a:r>
+          </a:p>
+          <a:p>
+            <a:r>
+              <a:t>A better model will not save you: https://github.com/BittahCriminal/build-your-own-chief-of-staff/blob/main/research/notes/better-models-wont-fix-the-process.md</a:t>
             </a:r>
           </a:p>
           <a:p/>
@@ -1787,7 +1787,7 @@
           <a:p/>
           <a:p>
             <a:r>
-              <a:t>Notion: https://app.notion.com/p/36f059b703e181d9bd25f984c8bd6945</a:t>
+              <a:t>Source: https://github.com/BittahCriminal/build-your-own-chief-of-staff/blob/main/research/notes/why-agent-projects-fail.md</a:t>
             </a:r>
           </a:p>
           <a:p/>
@@ -1863,7 +1863,7 @@
           <a:lstStyle/>
           <a:p>
             <a:r>
-              <a:t>Walk the left column: these are the eight portable jobs from the Delegation Kit, renamed into operator English. Notion: https://app.notion.com/p/36f059b703e18192a6d8f67fbe74b756</a:t>
+              <a:t>Walk the left column: these are the eight portable jobs from the Delegation Kit, renamed into operator English. Source: https://github.com/BittahCriminal/build-your-own-chief-of-staff/blob/main/research/notes/delegation-kit.md</a:t>
             </a:r>
           </a:p>
           <a:p/>
@@ -10302,7 +10302,7 @@
               </a:rPr>
               <a:t>Open START-HERE.md. Prompt kit, not the Claude plugin.
 Process files, CoS workflows, blank context templates, the decision matrix.
-Sources cited from the Notion Substack table.</a:t>
+Source notes live in research/SOURCES.md.</a:t>
             </a:r>
           </a:p>
         </p:txBody>

</xml_diff>